<commit_message>
update powerpoint and new paper
</commit_message>
<xml_diff>
--- a/Documents/Study.pptx
+++ b/Documents/Study.pptx
@@ -1498,7 +1498,7 @@
                 <a:ea typeface="Calibri" pitchFamily="34" charset="-122"/>
                 <a:cs typeface="Calibri" pitchFamily="34" charset="-120"/>
               </a:rPr>
-              <a:t>Does the form of an automation aid's reasoning explanation — holding decision-relevant information constant — change subjective transparency </a:t>
+              <a:t>Does the form of an automation aid's reasoning explanation — holding action-relevant information constant — change subjective transparency </a:t>
             </a:r>
             <a:r>
               <a:rPr lang="en-US" sz="1600" dirty="0">
@@ -2265,7 +2265,24 @@
                 </a:solidFill>
                 <a:effectLst/>
               </a:rPr>
-              <a:t>while holding the decision-relevant information constant. </a:t>
+              <a:t>while holding the </a:t>
+            </a:r>
+            <a:r>
+              <a:rPr lang="en-US" sz="1400" dirty="0">
+                <a:solidFill>
+                  <a:srgbClr val="3B3B3B"/>
+                </a:solidFill>
+              </a:rPr>
+              <a:t>action</a:t>
+            </a:r>
+            <a:r>
+              <a:rPr lang="en-US" sz="1400" b="0" i="0" dirty="0">
+                <a:solidFill>
+                  <a:srgbClr val="3B3B3B"/>
+                </a:solidFill>
+                <a:effectLst/>
+              </a:rPr>
+              <a:t>-relevant information constant. </a:t>
             </a:r>
             <a:endParaRPr lang="en-US" sz="1300" dirty="0">
               <a:solidFill>
@@ -2347,8 +2364,8 @@
         </p:nvSpPr>
         <p:spPr>
           <a:xfrm>
-            <a:off x="6309360" y="4428269"/>
-            <a:ext cx="5486400" cy="1831854"/>
+            <a:off x="6309360" y="4348756"/>
+            <a:ext cx="5486400" cy="2109691"/>
           </a:xfrm>
           <a:prstGeom prst="rect">
             <a:avLst/>
@@ -2426,7 +2443,7 @@
                 </a:solidFill>
                 <a:effectLst/>
               </a:rPr>
-              <a:t>. Our design holds decision-relevant content and varies </a:t>
+              <a:t>. Our design holds action-relevant content and varies </a:t>
             </a:r>
             <a:r>
               <a:rPr lang="en-US" sz="1300" b="1" dirty="0">
@@ -2460,13 +2477,21 @@
           <a:p>
             <a:pPr algn="l"/>
             <a:r>
+              <a:rPr lang="en-US" sz="1300" dirty="0">
+                <a:solidFill>
+                  <a:srgbClr val="3B3B3B"/>
+                </a:solidFill>
+              </a:rPr>
+              <a:t> The XAI literature shows that explanations can raise agreement and the feeling of being informed without improving the user's ability to catch AI mistakes (Bansal 2021), and that subjective understanding often rises without objective understanding (Wang &amp; Yin 2021) — but these results come from single-task settings. </a:t>
+            </a:r>
+            <a:r>
               <a:rPr lang="en-US" sz="1300" b="0" i="0" dirty="0">
                 <a:solidFill>
                   <a:srgbClr val="3B3B3B"/>
                 </a:solidFill>
                 <a:effectLst/>
               </a:rPr>
-              <a:t>The XAI literature (Wang &amp; Yin 2021, Bansal 2021) has shown explanations can raise trust without improving understanding, but only in one-shot decisions. We test the same dissociation under </a:t>
+              <a:t>We test the same dissociation under </a:t>
             </a:r>
             <a:r>
               <a:rPr lang="en-US" sz="1300" b="1" dirty="0">
@@ -2755,7 +2780,7 @@
         </p:nvSpPr>
         <p:spPr>
           <a:xfrm>
-            <a:off x="6309360" y="4021362"/>
+            <a:off x="6309360" y="3994858"/>
             <a:ext cx="5486400" cy="310896"/>
           </a:xfrm>
           <a:prstGeom prst="rect">
@@ -4051,7 +4076,7 @@
                 <a:ea typeface="Calibri" pitchFamily="34" charset="-122"/>
                 <a:cs typeface="Calibri" pitchFamily="34" charset="-120"/>
               </a:rPr>
-              <a:t>Same necessary decision-relevant facts as F1, reframed selectively and contrastively.</a:t>
+              <a:t>Same necessary action-relevant facts as F1, reframed selectively and contrastively.</a:t>
             </a:r>
             <a:endParaRPr lang="en-US" sz="1100" dirty="0"/>
           </a:p>
@@ -4966,7 +4991,7 @@
                 <a:ea typeface="Calibri" pitchFamily="34" charset="-122"/>
                 <a:cs typeface="Calibri" pitchFamily="34" charset="-120"/>
               </a:rPr>
-              <a:t>Does the form of an automation aid's reasoning explanation — holding decision-relevant information constant — change subjective transparency and whether the operator's mental model actually updates under multitasking load?</a:t>
+              <a:t>Does the form of an automation aid's reasoning explanation — holding action-relevant information constant — change subjective transparency and whether the operator's mental model actually updates under multitasking load?</a:t>
             </a:r>
             <a:endParaRPr lang="en-US" sz="1300" dirty="0"/>
           </a:p>
@@ -5117,7 +5142,29 @@
                 <a:ea typeface="Calibri" pitchFamily="34" charset="-122"/>
                 <a:cs typeface="Calibri" pitchFamily="34" charset="-120"/>
               </a:rPr>
-              <a:t>Subjective transparency favours verbose explanations</a:t>
+              <a:t>Subjective transparency  and subjective trust </a:t>
+            </a:r>
+            <a:r>
+              <a:rPr lang="en-US" sz="1200" b="1" dirty="0" err="1">
+                <a:solidFill>
+                  <a:srgbClr val="1A1A1A"/>
+                </a:solidFill>
+                <a:latin typeface="Calibri" pitchFamily="34" charset="0"/>
+                <a:ea typeface="Calibri" pitchFamily="34" charset="-122"/>
+                <a:cs typeface="Calibri" pitchFamily="34" charset="-120"/>
+              </a:rPr>
+              <a:t>favours</a:t>
+            </a:r>
+            <a:r>
+              <a:rPr lang="en-US" sz="1200" b="1" dirty="0">
+                <a:solidFill>
+                  <a:srgbClr val="1A1A1A"/>
+                </a:solidFill>
+                <a:latin typeface="Calibri" pitchFamily="34" charset="0"/>
+                <a:ea typeface="Calibri" pitchFamily="34" charset="-122"/>
+                <a:cs typeface="Calibri" pitchFamily="34" charset="-120"/>
+              </a:rPr>
+              <a:t> verbose explanations</a:t>
             </a:r>
             <a:endParaRPr lang="en-US" sz="1300" dirty="0"/>
           </a:p>
@@ -5156,7 +5203,7 @@
                 <a:ea typeface="Calibri" pitchFamily="34" charset="-122"/>
                 <a:cs typeface="Calibri" pitchFamily="34" charset="-120"/>
               </a:rPr>
-              <a:t>Participants will rate the verbose always-on explanation (F1) as more transparent than the selective explanations (F2/F3), even when decision-relevant information is held constant.</a:t>
+              <a:t>Participants will rate the verbose always-on explanation (F1) as more transparent and more trustworthy than the selective explanations (F2/F3) , even when action-relevant information is held constant.</a:t>
             </a:r>
             <a:endParaRPr lang="en-US" sz="1200" dirty="0"/>
           </a:p>
@@ -5295,7 +5342,7 @@
                 <a:ea typeface="Calibri" pitchFamily="34" charset="-122"/>
                 <a:cs typeface="Calibri" pitchFamily="34" charset="-120"/>
               </a:rPr>
-              <a:t>Participants exposed to selective and contrastive explanations (F2/F3) will achieve higher post-block mental-model accuracy than participants exposed to a verbose always-on explanation (F1), even when decision-relevant information is held constant.</a:t>
+              <a:t>Participants exposed to selective and contrastive explanations (F2/F3) will achieve higher post-block mental-model accuracy than participants exposed to a verbose always-on explanation (F1), even when action-relevant information is held constant.</a:t>
             </a:r>
             <a:endParaRPr lang="en-US" sz="1200" dirty="0"/>
           </a:p>
@@ -5325,6 +5372,13 @@
             <a:prstDash val="solid"/>
           </a:ln>
         </p:spPr>
+        <p:txBody>
+          <a:bodyPr/>
+          <a:lstStyle/>
+          <a:p>
+            <a:endParaRPr lang="de-DE" dirty="0"/>
+          </a:p>
+        </p:txBody>
       </p:sp>
       <p:sp>
         <p:nvSpPr>
@@ -5395,7 +5449,7 @@
                 <a:ea typeface="Calibri" pitchFamily="34" charset="-122"/>
                 <a:cs typeface="Calibri" pitchFamily="34" charset="-120"/>
               </a:rPr>
-              <a:t>Selectivity directs attention to anomalies</a:t>
+              <a:t>Selectivity directs attention to anomalies and improves </a:t>
             </a:r>
             <a:endParaRPr lang="en-US" sz="1300" dirty="0"/>
           </a:p>
@@ -5434,9 +5488,37 @@
                 <a:ea typeface="Calibri" pitchFamily="34" charset="-122"/>
                 <a:cs typeface="Calibri" pitchFamily="34" charset="-120"/>
               </a:rPr>
-              <a:t>Participants will detect a higher proportion of automation-missed events under selective explanations (F2/F3) than under a verbose always-on explanation (F1).</a:t>
-            </a:r>
-            <a:endParaRPr lang="en-US" sz="1200" dirty="0"/>
+              <a:t>A: Participants will detect a higher proportion of automation-missed events under selective explanations (F2/F3) than under a verbose always-on explanation (F1).</a:t>
+            </a:r>
+          </a:p>
+          <a:p>
+            <a:pPr marL="0" indent="0">
+              <a:buNone/>
+            </a:pPr>
+            <a:endParaRPr lang="en-US" sz="1200" dirty="0">
+              <a:solidFill>
+                <a:srgbClr val="1A1A1A"/>
+              </a:solidFill>
+              <a:latin typeface="Calibri" pitchFamily="34" charset="0"/>
+              <a:ea typeface="Calibri" pitchFamily="34" charset="-122"/>
+              <a:cs typeface="Calibri" pitchFamily="34" charset="-120"/>
+            </a:endParaRPr>
+          </a:p>
+          <a:p>
+            <a:pPr marL="0" indent="0">
+              <a:buNone/>
+            </a:pPr>
+            <a:r>
+              <a:rPr lang="en-US" sz="1200" dirty="0">
+                <a:solidFill>
+                  <a:srgbClr val="1A1A1A"/>
+                </a:solidFill>
+                <a:latin typeface="Calibri" pitchFamily="34" charset="0"/>
+                <a:ea typeface="Calibri" pitchFamily="34" charset="-122"/>
+                <a:cs typeface="Calibri" pitchFamily="34" charset="-120"/>
+              </a:rPr>
+              <a:t>B: Participants will less likely overwrite the aid even when it was right under (F2/F3) than under (F1).</a:t>
+            </a:r>
           </a:p>
         </p:txBody>
       </p:sp>
@@ -6127,7 +6209,7 @@
                 <a:ea typeface="Calibri" pitchFamily="34" charset="-122"/>
                 <a:cs typeface="Calibri" pitchFamily="34" charset="-120"/>
               </a:rPr>
-              <a:t>Runs only on system monitoring at ~78% reliability; the other two tasks compete for attention and are not aided.</a:t>
+              <a:t>Runs only on system monitoring at ~78% reliability; the other two tasks compete for attention and are not aided. Every automation miss is communicated, so that the operator can handle the event manually if the information is perceived and processed.</a:t>
             </a:r>
             <a:endParaRPr lang="en-US" sz="1400" dirty="0"/>
           </a:p>
@@ -6376,7 +6458,7 @@
                 </a:solidFill>
                 <a:latin typeface="-apple-system"/>
               </a:rPr>
-              <a:t>Two</a:t>
+              <a:t>Three</a:t>
             </a:r>
             <a:r>
               <a:rPr lang="de-DE" sz="1400" dirty="0">
@@ -7382,7 +7464,7 @@
         </p:nvSpPr>
         <p:spPr>
           <a:xfrm>
-            <a:off x="411480" y="1874520"/>
+            <a:off x="411480" y="1728748"/>
             <a:ext cx="5592928" cy="1234440"/>
           </a:xfrm>
           <a:prstGeom prst="rect">
@@ -7407,7 +7489,7 @@
         </p:nvSpPr>
         <p:spPr>
           <a:xfrm>
-            <a:off x="411480" y="1874520"/>
+            <a:off x="411480" y="1728748"/>
             <a:ext cx="73152" cy="1234440"/>
           </a:xfrm>
           <a:prstGeom prst="rect">
@@ -7432,7 +7514,7 @@
         </p:nvSpPr>
         <p:spPr>
           <a:xfrm>
-            <a:off x="576072" y="1947672"/>
+            <a:off x="576072" y="1801900"/>
             <a:ext cx="4312768" cy="274320"/>
           </a:xfrm>
           <a:prstGeom prst="rect">
@@ -7471,7 +7553,7 @@
         </p:nvSpPr>
         <p:spPr>
           <a:xfrm>
-            <a:off x="4952848" y="1965960"/>
+            <a:off x="4952848" y="1820188"/>
             <a:ext cx="868680" cy="237744"/>
           </a:xfrm>
           <a:prstGeom prst="rect">
@@ -7496,7 +7578,7 @@
         </p:nvSpPr>
         <p:spPr>
           <a:xfrm>
-            <a:off x="4952848" y="1975104"/>
+            <a:off x="4952848" y="1829332"/>
             <a:ext cx="868680" cy="219456"/>
           </a:xfrm>
           <a:prstGeom prst="rect">
@@ -7535,7 +7617,7 @@
         </p:nvSpPr>
         <p:spPr>
           <a:xfrm>
-            <a:off x="576072" y="2203704"/>
+            <a:off x="576072" y="2057932"/>
             <a:ext cx="5318608" cy="201168"/>
           </a:xfrm>
           <a:prstGeom prst="rect">
@@ -7574,7 +7656,7 @@
         </p:nvSpPr>
         <p:spPr>
           <a:xfrm>
-            <a:off x="576072" y="2404872"/>
+            <a:off x="576072" y="2259100"/>
             <a:ext cx="5318608" cy="640080"/>
           </a:xfrm>
           <a:prstGeom prst="rect">
@@ -7613,7 +7695,7 @@
         </p:nvSpPr>
         <p:spPr>
           <a:xfrm>
-            <a:off x="6187288" y="1874520"/>
+            <a:off x="6187288" y="1728748"/>
             <a:ext cx="5592928" cy="1234440"/>
           </a:xfrm>
           <a:prstGeom prst="rect">
@@ -7638,7 +7720,7 @@
         </p:nvSpPr>
         <p:spPr>
           <a:xfrm>
-            <a:off x="6187288" y="1874520"/>
+            <a:off x="6187288" y="1728748"/>
             <a:ext cx="73152" cy="1234440"/>
           </a:xfrm>
           <a:prstGeom prst="rect">
@@ -7663,7 +7745,7 @@
         </p:nvSpPr>
         <p:spPr>
           <a:xfrm>
-            <a:off x="6351880" y="1947672"/>
+            <a:off x="6351880" y="1801900"/>
             <a:ext cx="4312768" cy="274320"/>
           </a:xfrm>
           <a:prstGeom prst="rect">
@@ -7702,7 +7784,7 @@
         </p:nvSpPr>
         <p:spPr>
           <a:xfrm>
-            <a:off x="10728655" y="1965960"/>
+            <a:off x="10728655" y="1820188"/>
             <a:ext cx="868680" cy="237744"/>
           </a:xfrm>
           <a:prstGeom prst="rect">
@@ -7727,7 +7809,7 @@
         </p:nvSpPr>
         <p:spPr>
           <a:xfrm>
-            <a:off x="10728655" y="1975104"/>
+            <a:off x="10728655" y="1829332"/>
             <a:ext cx="868680" cy="219456"/>
           </a:xfrm>
           <a:prstGeom prst="rect">
@@ -7766,7 +7848,7 @@
         </p:nvSpPr>
         <p:spPr>
           <a:xfrm>
-            <a:off x="6351880" y="2203704"/>
+            <a:off x="6351880" y="2057932"/>
             <a:ext cx="5318608" cy="201168"/>
           </a:xfrm>
           <a:prstGeom prst="rect">
@@ -7805,7 +7887,7 @@
         </p:nvSpPr>
         <p:spPr>
           <a:xfrm>
-            <a:off x="6351880" y="2404872"/>
+            <a:off x="6351880" y="2259100"/>
             <a:ext cx="5318608" cy="640080"/>
           </a:xfrm>
           <a:prstGeom prst="rect">
@@ -7844,8 +7926,8 @@
         </p:nvSpPr>
         <p:spPr>
           <a:xfrm>
-            <a:off x="411480" y="3200400"/>
-            <a:ext cx="5592928" cy="1234440"/>
+            <a:off x="411480" y="3054628"/>
+            <a:ext cx="5592928" cy="881388"/>
           </a:xfrm>
           <a:prstGeom prst="rect">
             <a:avLst/>
@@ -7869,8 +7951,8 @@
         </p:nvSpPr>
         <p:spPr>
           <a:xfrm>
-            <a:off x="411480" y="3200400"/>
-            <a:ext cx="73152" cy="1234440"/>
+            <a:off x="411480" y="3054628"/>
+            <a:ext cx="73152" cy="890532"/>
           </a:xfrm>
           <a:prstGeom prst="rect">
             <a:avLst/>
@@ -7894,7 +7976,7 @@
         </p:nvSpPr>
         <p:spPr>
           <a:xfrm>
-            <a:off x="576072" y="3273552"/>
+            <a:off x="576072" y="3127780"/>
             <a:ext cx="4312768" cy="274320"/>
           </a:xfrm>
           <a:prstGeom prst="rect">
@@ -7933,7 +8015,7 @@
         </p:nvSpPr>
         <p:spPr>
           <a:xfrm>
-            <a:off x="4952848" y="3291840"/>
+            <a:off x="4952848" y="3146068"/>
             <a:ext cx="868680" cy="237744"/>
           </a:xfrm>
           <a:prstGeom prst="rect">
@@ -7958,7 +8040,7 @@
         </p:nvSpPr>
         <p:spPr>
           <a:xfrm>
-            <a:off x="4952848" y="3300984"/>
+            <a:off x="4952848" y="3155212"/>
             <a:ext cx="868680" cy="219456"/>
           </a:xfrm>
           <a:prstGeom prst="rect">
@@ -7997,7 +8079,7 @@
         </p:nvSpPr>
         <p:spPr>
           <a:xfrm>
-            <a:off x="576072" y="3529584"/>
+            <a:off x="576072" y="3383812"/>
             <a:ext cx="5318608" cy="201168"/>
           </a:xfrm>
           <a:prstGeom prst="rect">
@@ -8036,8 +8118,8 @@
         </p:nvSpPr>
         <p:spPr>
           <a:xfrm>
-            <a:off x="576072" y="3730752"/>
-            <a:ext cx="5318608" cy="640080"/>
+            <a:off x="576072" y="3584980"/>
+            <a:ext cx="5318608" cy="360180"/>
           </a:xfrm>
           <a:prstGeom prst="rect">
             <a:avLst/>
@@ -8075,8 +8157,8 @@
         </p:nvSpPr>
         <p:spPr>
           <a:xfrm>
-            <a:off x="6187288" y="3200400"/>
-            <a:ext cx="5592928" cy="1234440"/>
+            <a:off x="6188611" y="3068236"/>
+            <a:ext cx="5592928" cy="881388"/>
           </a:xfrm>
           <a:prstGeom prst="rect">
             <a:avLst/>
@@ -8091,6 +8173,13 @@
             <a:prstDash val="solid"/>
           </a:ln>
         </p:spPr>
+        <p:txBody>
+          <a:bodyPr/>
+          <a:lstStyle/>
+          <a:p>
+            <a:endParaRPr lang="de-DE" dirty="0"/>
+          </a:p>
+        </p:txBody>
       </p:sp>
       <p:sp>
         <p:nvSpPr>
@@ -8100,8 +8189,8 @@
         </p:nvSpPr>
         <p:spPr>
           <a:xfrm>
-            <a:off x="6187288" y="3200400"/>
-            <a:ext cx="73152" cy="1234440"/>
+            <a:off x="6187288" y="3067880"/>
+            <a:ext cx="73152" cy="881388"/>
           </a:xfrm>
           <a:prstGeom prst="rect">
             <a:avLst/>
@@ -8125,7 +8214,7 @@
         </p:nvSpPr>
         <p:spPr>
           <a:xfrm>
-            <a:off x="6351880" y="3273552"/>
+            <a:off x="6351880" y="3141032"/>
             <a:ext cx="4312768" cy="274320"/>
           </a:xfrm>
           <a:prstGeom prst="rect">
@@ -8150,7 +8239,7 @@
                 <a:ea typeface="Calibri" pitchFamily="34" charset="-122"/>
                 <a:cs typeface="Calibri" pitchFamily="34" charset="-120"/>
               </a:rPr>
-              <a:t>Non-automated task performance</a:t>
+              <a:t>Subjective trust</a:t>
             </a:r>
             <a:endParaRPr lang="en-US" sz="1200" dirty="0"/>
           </a:p>
@@ -8164,7 +8253,7 @@
         </p:nvSpPr>
         <p:spPr>
           <a:xfrm>
-            <a:off x="10728655" y="3291840"/>
+            <a:off x="10728655" y="3192450"/>
             <a:ext cx="868680" cy="237744"/>
           </a:xfrm>
           <a:prstGeom prst="rect">
@@ -8180,6 +8269,13 @@
             <a:prstDash val="solid"/>
           </a:ln>
         </p:spPr>
+        <p:txBody>
+          <a:bodyPr/>
+          <a:lstStyle/>
+          <a:p>
+            <a:endParaRPr lang="de-DE" dirty="0"/>
+          </a:p>
+        </p:txBody>
       </p:sp>
       <p:sp>
         <p:nvSpPr>
@@ -8189,7 +8285,7 @@
         </p:nvSpPr>
         <p:spPr>
           <a:xfrm>
-            <a:off x="10728655" y="3300984"/>
+            <a:off x="10728655" y="3188342"/>
             <a:ext cx="868680" cy="219456"/>
           </a:xfrm>
           <a:prstGeom prst="rect">
@@ -8214,7 +8310,7 @@
                 <a:ea typeface="Calibri" pitchFamily="34" charset="-122"/>
                 <a:cs typeface="Calibri" pitchFamily="34" charset="-120"/>
               </a:rPr>
-              <a:t>H4</a:t>
+              <a:t>H1</a:t>
             </a:r>
             <a:endParaRPr lang="en-US" sz="1000" dirty="0"/>
           </a:p>
@@ -8228,7 +8324,7 @@
         </p:nvSpPr>
         <p:spPr>
           <a:xfrm>
-            <a:off x="6351880" y="3529584"/>
+            <a:off x="6351880" y="3397064"/>
             <a:ext cx="5318608" cy="201168"/>
           </a:xfrm>
           <a:prstGeom prst="rect">
@@ -8253,7 +8349,7 @@
                 <a:ea typeface="Calibri" pitchFamily="34" charset="-122"/>
                 <a:cs typeface="Calibri" pitchFamily="34" charset="-120"/>
               </a:rPr>
-              <a:t>Platform log</a:t>
+              <a:t>Questionnaire · after each block</a:t>
             </a:r>
             <a:endParaRPr lang="en-US" sz="900" dirty="0"/>
           </a:p>
@@ -8267,8 +8363,8 @@
         </p:nvSpPr>
         <p:spPr>
           <a:xfrm>
-            <a:off x="6351880" y="3730752"/>
-            <a:ext cx="5318608" cy="640080"/>
+            <a:off x="6351880" y="3598232"/>
+            <a:ext cx="5318608" cy="360180"/>
           </a:xfrm>
           <a:prstGeom prst="rect">
             <a:avLst/>
@@ -8280,8 +8376,9 @@
           <a:bodyPr wrap="square" lIns="0" tIns="0" rIns="0" bIns="0" rtlCol="0" anchor="t"/>
           <a:lstStyle/>
           <a:p>
-            <a:pPr marL="0" indent="0">
-              <a:buNone/>
+            <a:pPr algn="l">
+              <a:buFont typeface="+mj-lt"/>
+              <a:buAutoNum type="arabicPeriod"/>
             </a:pPr>
             <a:r>
               <a:rPr lang="en-US" sz="1050" dirty="0">
@@ -8292,8 +8389,83 @@
                 <a:ea typeface="Calibri" pitchFamily="34" charset="-122"/>
                 <a:cs typeface="Calibri" pitchFamily="34" charset="-120"/>
               </a:rPr>
-              <a:t>Communications: whether each radio call was answered correctly and how quickly. Resource Management: How stable the tank level was held. These tasks the aid does not help with — so they reveal whether reading less in the panel actually frees attention elsewhere.</a:t>
-            </a:r>
+              <a:t>Several rating like “</a:t>
+            </a:r>
+            <a:r>
+              <a:rPr lang="en-US" sz="1050" b="0" i="0" dirty="0">
+                <a:solidFill>
+                  <a:srgbClr val="3B3B3B"/>
+                </a:solidFill>
+                <a:effectLst/>
+                <a:latin typeface="-apple-system"/>
+              </a:rPr>
+              <a:t>The aid is </a:t>
+            </a:r>
+            <a:r>
+              <a:rPr lang="en-US" sz="1050" i="0" dirty="0">
+                <a:solidFill>
+                  <a:srgbClr val="3B3B3B"/>
+                </a:solidFill>
+                <a:effectLst/>
+                <a:latin typeface="-apple-system"/>
+              </a:rPr>
+              <a:t>dependable</a:t>
+            </a:r>
+            <a:r>
+              <a:rPr lang="en-US" sz="1050" b="0" i="0" dirty="0">
+                <a:solidFill>
+                  <a:srgbClr val="3B3B3B"/>
+                </a:solidFill>
+                <a:effectLst/>
+                <a:latin typeface="-apple-system"/>
+              </a:rPr>
+              <a:t>.”, “The aid is </a:t>
+            </a:r>
+            <a:r>
+              <a:rPr lang="en-US" sz="1050" i="0" dirty="0">
+                <a:solidFill>
+                  <a:srgbClr val="3B3B3B"/>
+                </a:solidFill>
+                <a:effectLst/>
+                <a:latin typeface="-apple-system"/>
+              </a:rPr>
+              <a:t>reliable</a:t>
+            </a:r>
+            <a:r>
+              <a:rPr lang="en-US" sz="1050" b="0" i="0" dirty="0">
+                <a:solidFill>
+                  <a:srgbClr val="3B3B3B"/>
+                </a:solidFill>
+                <a:effectLst/>
+                <a:latin typeface="-apple-system"/>
+              </a:rPr>
+              <a:t>.”, “I am </a:t>
+            </a:r>
+            <a:r>
+              <a:rPr lang="en-US" sz="1050" i="0" dirty="0">
+                <a:solidFill>
+                  <a:srgbClr val="3B3B3B"/>
+                </a:solidFill>
+                <a:effectLst/>
+                <a:latin typeface="-apple-system"/>
+              </a:rPr>
+              <a:t>confident</a:t>
+            </a:r>
+            <a:r>
+              <a:rPr lang="en-US" sz="1050" b="0" i="0" dirty="0">
+                <a:solidFill>
+                  <a:srgbClr val="3B3B3B"/>
+                </a:solidFill>
+                <a:effectLst/>
+                <a:latin typeface="-apple-system"/>
+              </a:rPr>
+              <a:t> in the aid.”, … to capture subjective trust.</a:t>
+            </a:r>
+          </a:p>
+          <a:p>
+            <a:pPr marL="0" indent="0">
+              <a:buNone/>
+            </a:pPr>
             <a:endParaRPr lang="en-US" sz="1050" dirty="0"/>
           </a:p>
         </p:txBody>
@@ -8306,8 +8478,8 @@
         </p:nvSpPr>
         <p:spPr>
           <a:xfrm>
-            <a:off x="411480" y="4572000"/>
-            <a:ext cx="11368735" cy="1417320"/>
+            <a:off x="411480" y="5216708"/>
+            <a:ext cx="11368735" cy="1156920"/>
           </a:xfrm>
           <a:prstGeom prst="rect">
             <a:avLst/>
@@ -8338,8 +8510,8 @@
         </p:nvSpPr>
         <p:spPr>
           <a:xfrm>
-            <a:off x="411480" y="4572000"/>
-            <a:ext cx="91440" cy="1417320"/>
+            <a:off x="411480" y="5216708"/>
+            <a:ext cx="73152" cy="1156920"/>
           </a:xfrm>
           <a:prstGeom prst="rect">
             <a:avLst/>
@@ -8363,7 +8535,7 @@
         </p:nvSpPr>
         <p:spPr>
           <a:xfrm>
-            <a:off x="640080" y="4626864"/>
+            <a:off x="571500" y="5216708"/>
             <a:ext cx="11140135" cy="274320"/>
           </a:xfrm>
           <a:prstGeom prst="rect">
@@ -8402,8 +8574,8 @@
         </p:nvSpPr>
         <p:spPr>
           <a:xfrm>
-            <a:off x="640080" y="4901184"/>
-            <a:ext cx="11140135" cy="1097280"/>
+            <a:off x="576072" y="5523496"/>
+            <a:ext cx="11140135" cy="795268"/>
           </a:xfrm>
           <a:prstGeom prst="rect">
             <a:avLst/>
@@ -8415,11 +8587,12 @@
           <a:bodyPr wrap="square" lIns="0" tIns="0" rIns="0" bIns="0" rtlCol="0" anchor="t"/>
           <a:lstStyle/>
           <a:p>
-            <a:pPr marL="0" indent="0">
+            <a:pPr marL="171450" indent="-171450">
               <a:spcAft>
                 <a:spcPts val="200"/>
               </a:spcAft>
-              <a:buNone/>
+              <a:buFont typeface="Arial" panose="020B0604020202020204" pitchFamily="34" charset="0"/>
+              <a:buChar char="•"/>
             </a:pPr>
             <a:r>
               <a:rPr lang="en-US" sz="1100" dirty="0">
@@ -8430,16 +8603,17 @@
                 <a:ea typeface="Calibri" pitchFamily="34" charset="-122"/>
                 <a:cs typeface="Calibri" pitchFamily="34" charset="-120"/>
               </a:rPr>
-              <a:t>Content matching across F1/F2/F3 is the central design constraint — any leak invalidates the form-vs-content comparison.</a:t>
+              <a:t>F1 → F2 changes three factors simultaneously (selectivity + contrastiveness + framing). Treated as a package-level test of "form", not as three isolated effects; F3 − F2 isolates the actionable cue.</a:t>
             </a:r>
             <a:endParaRPr lang="en-US" sz="1100" dirty="0"/>
           </a:p>
           <a:p>
-            <a:pPr marL="0" indent="0">
+            <a:pPr marL="171450" indent="-171450">
               <a:spcAft>
                 <a:spcPts val="200"/>
               </a:spcAft>
-              <a:buNone/>
+              <a:buFont typeface="Arial" panose="020B0604020202020204" pitchFamily="34" charset="0"/>
+              <a:buChar char="•"/>
             </a:pPr>
             <a:r>
               <a:rPr lang="en-US" sz="1100" dirty="0">
@@ -8450,16 +8624,16 @@
                 <a:ea typeface="Calibri" pitchFamily="34" charset="-122"/>
                 <a:cs typeface="Calibri" pitchFamily="34" charset="-120"/>
               </a:rPr>
-              <a:t>F1 → F2 changes three factors simultaneously (selectivity + contrastiveness + framing). Treated as a package-level test of "form", not as three isolated effects; F3 − F2 isolates the actionable cue.</a:t>
-            </a:r>
-            <a:endParaRPr lang="en-US" sz="1100" dirty="0"/>
-          </a:p>
-          <a:p>
-            <a:pPr marL="0" indent="0">
+              <a:t>Load is held at a single moderate level; generalisation across load levels cannot be done since the load level is held constant.</a:t>
+            </a:r>
+          </a:p>
+          <a:p>
+            <a:pPr marL="171450" indent="-171450">
               <a:spcAft>
                 <a:spcPts val="200"/>
               </a:spcAft>
-              <a:buNone/>
+              <a:buFont typeface="Arial" panose="020B0604020202020204" pitchFamily="34" charset="0"/>
+              <a:buChar char="•"/>
             </a:pPr>
             <a:r>
               <a:rPr lang="en-US" sz="1100" dirty="0">
@@ -8470,9 +8644,620 @@
                 <a:ea typeface="Calibri" pitchFamily="34" charset="-122"/>
                 <a:cs typeface="Calibri" pitchFamily="34" charset="-120"/>
               </a:rPr>
-              <a:t>Load is held at a single moderate level; generalisation across load levels cannot be done since the load level is held constant.</a:t>
-            </a:r>
+              <a:t>The number of automation aid misses is small (3) in the 5 min block. Reliable statistic on such small number is difficult.</a:t>
+            </a:r>
+          </a:p>
+          <a:p>
+            <a:pPr marL="171450" indent="-171450">
+              <a:spcAft>
+                <a:spcPts val="200"/>
+              </a:spcAft>
+              <a:buFont typeface="Arial" panose="020B0604020202020204" pitchFamily="34" charset="0"/>
+              <a:buChar char="•"/>
+            </a:pPr>
+            <a:r>
+              <a:rPr lang="en-US" sz="1100" dirty="0">
+                <a:solidFill>
+                  <a:srgbClr val="1A1A1A"/>
+                </a:solidFill>
+                <a:latin typeface="Calibri" pitchFamily="34" charset="0"/>
+                <a:ea typeface="Calibri" pitchFamily="34" charset="-122"/>
+                <a:cs typeface="Calibri" pitchFamily="34" charset="-120"/>
+              </a:rPr>
+              <a:t>The number of participants might be to low to see any effect </a:t>
+            </a:r>
+            <a:r>
+              <a:rPr lang="en-US" sz="1100">
+                <a:solidFill>
+                  <a:srgbClr val="1A1A1A"/>
+                </a:solidFill>
+                <a:latin typeface="Calibri" pitchFamily="34" charset="0"/>
+                <a:ea typeface="Calibri" pitchFamily="34" charset="-122"/>
+                <a:cs typeface="Calibri" pitchFamily="34" charset="-120"/>
+              </a:rPr>
+              <a:t>with significance.</a:t>
+            </a:r>
+            <a:endParaRPr lang="en-US" sz="1100" dirty="0">
+              <a:solidFill>
+                <a:srgbClr val="1A1A1A"/>
+              </a:solidFill>
+              <a:latin typeface="Calibri" pitchFamily="34" charset="0"/>
+              <a:ea typeface="Calibri" pitchFamily="34" charset="-122"/>
+              <a:cs typeface="Calibri" pitchFamily="34" charset="-120"/>
+            </a:endParaRPr>
+          </a:p>
+          <a:p>
+            <a:pPr marL="171450" indent="-171450">
+              <a:spcAft>
+                <a:spcPts val="200"/>
+              </a:spcAft>
+              <a:buFont typeface="Arial" panose="020B0604020202020204" pitchFamily="34" charset="0"/>
+              <a:buChar char="•"/>
+            </a:pPr>
+            <a:endParaRPr lang="en-US" sz="1100" dirty="0">
+              <a:solidFill>
+                <a:srgbClr val="1A1A1A"/>
+              </a:solidFill>
+              <a:latin typeface="Calibri" pitchFamily="34" charset="0"/>
+              <a:ea typeface="Calibri" pitchFamily="34" charset="-122"/>
+              <a:cs typeface="Calibri" pitchFamily="34" charset="-120"/>
+            </a:endParaRPr>
+          </a:p>
+          <a:p>
+            <a:pPr marL="171450" indent="-171450">
+              <a:spcAft>
+                <a:spcPts val="200"/>
+              </a:spcAft>
+              <a:buFont typeface="Arial" panose="020B0604020202020204" pitchFamily="34" charset="0"/>
+              <a:buChar char="•"/>
+            </a:pPr>
             <a:endParaRPr lang="en-US" sz="1100" dirty="0"/>
+          </a:p>
+        </p:txBody>
+      </p:sp>
+      <p:sp>
+        <p:nvSpPr>
+          <p:cNvPr id="45" name="Shape 25">
+            <a:extLst>
+              <a:ext uri="{FF2B5EF4-FFF2-40B4-BE49-F238E27FC236}">
+                <a16:creationId xmlns:a16="http://schemas.microsoft.com/office/drawing/2014/main" id="{99C447DA-64F6-9732-7CE3-36A58AD49D20}"/>
+              </a:ext>
+            </a:extLst>
+          </p:cNvPr>
+          <p:cNvSpPr/>
+          <p:nvPr/>
+        </p:nvSpPr>
+        <p:spPr>
+          <a:xfrm>
+            <a:off x="411480" y="4064032"/>
+            <a:ext cx="5592928" cy="881388"/>
+          </a:xfrm>
+          <a:prstGeom prst="rect">
+            <a:avLst/>
+          </a:prstGeom>
+          <a:solidFill>
+            <a:srgbClr val="FFFFFF"/>
+          </a:solidFill>
+          <a:ln w="9525">
+            <a:solidFill>
+              <a:srgbClr val="C9D2D9"/>
+            </a:solidFill>
+            <a:prstDash val="solid"/>
+          </a:ln>
+        </p:spPr>
+      </p:sp>
+      <p:sp>
+        <p:nvSpPr>
+          <p:cNvPr id="46" name="Shape 26">
+            <a:extLst>
+              <a:ext uri="{FF2B5EF4-FFF2-40B4-BE49-F238E27FC236}">
+                <a16:creationId xmlns:a16="http://schemas.microsoft.com/office/drawing/2014/main" id="{C54ADFFC-B13F-60CC-0062-7E355B108C72}"/>
+              </a:ext>
+            </a:extLst>
+          </p:cNvPr>
+          <p:cNvSpPr/>
+          <p:nvPr/>
+        </p:nvSpPr>
+        <p:spPr>
+          <a:xfrm>
+            <a:off x="411480" y="4064032"/>
+            <a:ext cx="73152" cy="890532"/>
+          </a:xfrm>
+          <a:prstGeom prst="rect">
+            <a:avLst/>
+          </a:prstGeom>
+          <a:solidFill>
+            <a:srgbClr val="143847"/>
+          </a:solidFill>
+          <a:ln w="12700">
+            <a:solidFill>
+              <a:srgbClr val="143847"/>
+            </a:solidFill>
+            <a:prstDash val="solid"/>
+          </a:ln>
+        </p:spPr>
+      </p:sp>
+      <p:sp>
+        <p:nvSpPr>
+          <p:cNvPr id="47" name="Text 27">
+            <a:extLst>
+              <a:ext uri="{FF2B5EF4-FFF2-40B4-BE49-F238E27FC236}">
+                <a16:creationId xmlns:a16="http://schemas.microsoft.com/office/drawing/2014/main" id="{F42547AA-4F5D-2BCB-6159-5BA3693CED59}"/>
+              </a:ext>
+            </a:extLst>
+          </p:cNvPr>
+          <p:cNvSpPr/>
+          <p:nvPr/>
+        </p:nvSpPr>
+        <p:spPr>
+          <a:xfrm>
+            <a:off x="576072" y="4137184"/>
+            <a:ext cx="4312768" cy="274320"/>
+          </a:xfrm>
+          <a:prstGeom prst="rect">
+            <a:avLst/>
+          </a:prstGeom>
+          <a:noFill/>
+          <a:ln/>
+        </p:spPr>
+        <p:txBody>
+          <a:bodyPr wrap="square" lIns="0" tIns="0" rIns="0" bIns="0" rtlCol="0" anchor="ctr"/>
+          <a:lstStyle/>
+          <a:p>
+            <a:pPr marL="0" indent="0">
+              <a:buNone/>
+            </a:pPr>
+            <a:r>
+              <a:rPr lang="en-US" sz="1200" b="1" dirty="0">
+                <a:solidFill>
+                  <a:srgbClr val="143847"/>
+                </a:solidFill>
+                <a:latin typeface="Calibri" pitchFamily="34" charset="0"/>
+                <a:ea typeface="Calibri" pitchFamily="34" charset="-122"/>
+                <a:cs typeface="Calibri" pitchFamily="34" charset="-120"/>
+              </a:rPr>
+              <a:t>Detection of automation aid overwrites</a:t>
+            </a:r>
+            <a:endParaRPr lang="en-US" sz="1200" dirty="0"/>
+          </a:p>
+        </p:txBody>
+      </p:sp>
+      <p:sp>
+        <p:nvSpPr>
+          <p:cNvPr id="48" name="Shape 28">
+            <a:extLst>
+              <a:ext uri="{FF2B5EF4-FFF2-40B4-BE49-F238E27FC236}">
+                <a16:creationId xmlns:a16="http://schemas.microsoft.com/office/drawing/2014/main" id="{9A15BC7B-8947-66EA-2DAA-5847DE24B6B8}"/>
+              </a:ext>
+            </a:extLst>
+          </p:cNvPr>
+          <p:cNvSpPr/>
+          <p:nvPr/>
+        </p:nvSpPr>
+        <p:spPr>
+          <a:xfrm>
+            <a:off x="4952848" y="4155472"/>
+            <a:ext cx="868680" cy="237744"/>
+          </a:xfrm>
+          <a:prstGeom prst="rect">
+            <a:avLst/>
+          </a:prstGeom>
+          <a:solidFill>
+            <a:srgbClr val="143847"/>
+          </a:solidFill>
+          <a:ln w="12700">
+            <a:solidFill>
+              <a:srgbClr val="143847"/>
+            </a:solidFill>
+            <a:prstDash val="solid"/>
+          </a:ln>
+        </p:spPr>
+      </p:sp>
+      <p:sp>
+        <p:nvSpPr>
+          <p:cNvPr id="49" name="Text 29">
+            <a:extLst>
+              <a:ext uri="{FF2B5EF4-FFF2-40B4-BE49-F238E27FC236}">
+                <a16:creationId xmlns:a16="http://schemas.microsoft.com/office/drawing/2014/main" id="{E624EB60-3DAB-B407-D16C-AE6F878AC49D}"/>
+              </a:ext>
+            </a:extLst>
+          </p:cNvPr>
+          <p:cNvSpPr/>
+          <p:nvPr/>
+        </p:nvSpPr>
+        <p:spPr>
+          <a:xfrm>
+            <a:off x="4952848" y="4164616"/>
+            <a:ext cx="868680" cy="219456"/>
+          </a:xfrm>
+          <a:prstGeom prst="rect">
+            <a:avLst/>
+          </a:prstGeom>
+          <a:noFill/>
+          <a:ln/>
+        </p:spPr>
+        <p:txBody>
+          <a:bodyPr wrap="square" lIns="0" tIns="0" rIns="0" bIns="0" rtlCol="0" anchor="ctr"/>
+          <a:lstStyle/>
+          <a:p>
+            <a:pPr marL="0" indent="0" algn="ctr">
+              <a:buNone/>
+            </a:pPr>
+            <a:r>
+              <a:rPr lang="en-US" sz="1000" b="1" dirty="0">
+                <a:solidFill>
+                  <a:srgbClr val="FFFFFF"/>
+                </a:solidFill>
+                <a:latin typeface="Calibri" pitchFamily="34" charset="0"/>
+                <a:ea typeface="Calibri" pitchFamily="34" charset="-122"/>
+                <a:cs typeface="Calibri" pitchFamily="34" charset="-120"/>
+              </a:rPr>
+              <a:t>H3</a:t>
+            </a:r>
+            <a:endParaRPr lang="en-US" sz="1000" dirty="0"/>
+          </a:p>
+        </p:txBody>
+      </p:sp>
+      <p:sp>
+        <p:nvSpPr>
+          <p:cNvPr id="50" name="Text 30">
+            <a:extLst>
+              <a:ext uri="{FF2B5EF4-FFF2-40B4-BE49-F238E27FC236}">
+                <a16:creationId xmlns:a16="http://schemas.microsoft.com/office/drawing/2014/main" id="{AB7D5820-663E-5810-A09A-8A9FC168AC4E}"/>
+              </a:ext>
+            </a:extLst>
+          </p:cNvPr>
+          <p:cNvSpPr/>
+          <p:nvPr/>
+        </p:nvSpPr>
+        <p:spPr>
+          <a:xfrm>
+            <a:off x="576072" y="4393216"/>
+            <a:ext cx="5318608" cy="201168"/>
+          </a:xfrm>
+          <a:prstGeom prst="rect">
+            <a:avLst/>
+          </a:prstGeom>
+          <a:noFill/>
+          <a:ln/>
+        </p:spPr>
+        <p:txBody>
+          <a:bodyPr wrap="square" lIns="0" tIns="0" rIns="0" bIns="0" rtlCol="0" anchor="ctr"/>
+          <a:lstStyle/>
+          <a:p>
+            <a:pPr marL="0" indent="0">
+              <a:buNone/>
+            </a:pPr>
+            <a:r>
+              <a:rPr lang="en-US" sz="900" i="1" dirty="0">
+                <a:solidFill>
+                  <a:srgbClr val="5A6770"/>
+                </a:solidFill>
+                <a:latin typeface="Calibri" pitchFamily="34" charset="0"/>
+                <a:ea typeface="Calibri" pitchFamily="34" charset="-122"/>
+                <a:cs typeface="Calibri" pitchFamily="34" charset="-120"/>
+              </a:rPr>
+              <a:t>Platform log</a:t>
+            </a:r>
+            <a:endParaRPr lang="en-US" sz="900" dirty="0"/>
+          </a:p>
+        </p:txBody>
+      </p:sp>
+      <p:sp>
+        <p:nvSpPr>
+          <p:cNvPr id="51" name="Text 31">
+            <a:extLst>
+              <a:ext uri="{FF2B5EF4-FFF2-40B4-BE49-F238E27FC236}">
+                <a16:creationId xmlns:a16="http://schemas.microsoft.com/office/drawing/2014/main" id="{08E071E0-5CF2-2F82-6247-9E3742CEACB1}"/>
+              </a:ext>
+            </a:extLst>
+          </p:cNvPr>
+          <p:cNvSpPr/>
+          <p:nvPr/>
+        </p:nvSpPr>
+        <p:spPr>
+          <a:xfrm>
+            <a:off x="576072" y="4594384"/>
+            <a:ext cx="5318608" cy="360180"/>
+          </a:xfrm>
+          <a:prstGeom prst="rect">
+            <a:avLst/>
+          </a:prstGeom>
+          <a:noFill/>
+          <a:ln/>
+        </p:spPr>
+        <p:txBody>
+          <a:bodyPr wrap="square" lIns="0" tIns="0" rIns="0" bIns="0" rtlCol="0" anchor="t"/>
+          <a:lstStyle/>
+          <a:p>
+            <a:pPr marL="0" indent="0">
+              <a:buNone/>
+            </a:pPr>
+            <a:r>
+              <a:rPr lang="en-US" sz="1050" dirty="0">
+                <a:solidFill>
+                  <a:srgbClr val="1A1A1A"/>
+                </a:solidFill>
+                <a:latin typeface="Calibri" pitchFamily="34" charset="0"/>
+                <a:ea typeface="Calibri" pitchFamily="34" charset="-122"/>
+                <a:cs typeface="Calibri" pitchFamily="34" charset="-120"/>
+              </a:rPr>
+              <a:t>Whenever the aid handles an event, the participant should not intervene. We this record interventions.</a:t>
+            </a:r>
+            <a:endParaRPr lang="en-US" sz="1050" dirty="0"/>
+          </a:p>
+        </p:txBody>
+      </p:sp>
+      <p:sp>
+        <p:nvSpPr>
+          <p:cNvPr id="52" name="Shape 32">
+            <a:extLst>
+              <a:ext uri="{FF2B5EF4-FFF2-40B4-BE49-F238E27FC236}">
+                <a16:creationId xmlns:a16="http://schemas.microsoft.com/office/drawing/2014/main" id="{25BB157E-64B4-E872-D51E-CCAD61F59AA9}"/>
+              </a:ext>
+            </a:extLst>
+          </p:cNvPr>
+          <p:cNvSpPr/>
+          <p:nvPr/>
+        </p:nvSpPr>
+        <p:spPr>
+          <a:xfrm>
+            <a:off x="6187290" y="4075046"/>
+            <a:ext cx="5592928" cy="881388"/>
+          </a:xfrm>
+          <a:prstGeom prst="rect">
+            <a:avLst/>
+          </a:prstGeom>
+          <a:solidFill>
+            <a:srgbClr val="FFFFFF"/>
+          </a:solidFill>
+          <a:ln w="9525">
+            <a:solidFill>
+              <a:srgbClr val="C9D2D9"/>
+            </a:solidFill>
+            <a:prstDash val="solid"/>
+          </a:ln>
+        </p:spPr>
+      </p:sp>
+      <p:sp>
+        <p:nvSpPr>
+          <p:cNvPr id="53" name="Shape 33">
+            <a:extLst>
+              <a:ext uri="{FF2B5EF4-FFF2-40B4-BE49-F238E27FC236}">
+                <a16:creationId xmlns:a16="http://schemas.microsoft.com/office/drawing/2014/main" id="{EC34306C-7E89-05B2-B5AF-FBA55BF3B6C7}"/>
+              </a:ext>
+            </a:extLst>
+          </p:cNvPr>
+          <p:cNvSpPr/>
+          <p:nvPr/>
+        </p:nvSpPr>
+        <p:spPr>
+          <a:xfrm>
+            <a:off x="6187290" y="4075046"/>
+            <a:ext cx="73152" cy="881388"/>
+          </a:xfrm>
+          <a:prstGeom prst="rect">
+            <a:avLst/>
+          </a:prstGeom>
+          <a:solidFill>
+            <a:srgbClr val="143847"/>
+          </a:solidFill>
+          <a:ln w="12700">
+            <a:solidFill>
+              <a:srgbClr val="143847"/>
+            </a:solidFill>
+            <a:prstDash val="solid"/>
+          </a:ln>
+        </p:spPr>
+      </p:sp>
+      <p:sp>
+        <p:nvSpPr>
+          <p:cNvPr id="54" name="Text 34">
+            <a:extLst>
+              <a:ext uri="{FF2B5EF4-FFF2-40B4-BE49-F238E27FC236}">
+                <a16:creationId xmlns:a16="http://schemas.microsoft.com/office/drawing/2014/main" id="{C9C70177-BE3B-3824-C39D-D2A42BE0FFC1}"/>
+              </a:ext>
+            </a:extLst>
+          </p:cNvPr>
+          <p:cNvSpPr/>
+          <p:nvPr/>
+        </p:nvSpPr>
+        <p:spPr>
+          <a:xfrm>
+            <a:off x="6351882" y="4148198"/>
+            <a:ext cx="4312768" cy="274320"/>
+          </a:xfrm>
+          <a:prstGeom prst="rect">
+            <a:avLst/>
+          </a:prstGeom>
+          <a:noFill/>
+          <a:ln/>
+        </p:spPr>
+        <p:txBody>
+          <a:bodyPr wrap="square" lIns="0" tIns="0" rIns="0" bIns="0" rtlCol="0" anchor="ctr"/>
+          <a:lstStyle/>
+          <a:p>
+            <a:pPr marL="0" indent="0">
+              <a:buNone/>
+            </a:pPr>
+            <a:r>
+              <a:rPr lang="en-US" sz="1200" b="1" dirty="0">
+                <a:solidFill>
+                  <a:srgbClr val="143847"/>
+                </a:solidFill>
+                <a:latin typeface="Calibri" pitchFamily="34" charset="0"/>
+                <a:ea typeface="Calibri" pitchFamily="34" charset="-122"/>
+                <a:cs typeface="Calibri" pitchFamily="34" charset="-120"/>
+              </a:rPr>
+              <a:t>Non-automated task performance</a:t>
+            </a:r>
+            <a:endParaRPr lang="en-US" sz="1200" dirty="0"/>
+          </a:p>
+        </p:txBody>
+      </p:sp>
+      <p:sp>
+        <p:nvSpPr>
+          <p:cNvPr id="55" name="Shape 35">
+            <a:extLst>
+              <a:ext uri="{FF2B5EF4-FFF2-40B4-BE49-F238E27FC236}">
+                <a16:creationId xmlns:a16="http://schemas.microsoft.com/office/drawing/2014/main" id="{DC92547C-188D-694A-F08E-519F2DB088C1}"/>
+              </a:ext>
+            </a:extLst>
+          </p:cNvPr>
+          <p:cNvSpPr/>
+          <p:nvPr/>
+        </p:nvSpPr>
+        <p:spPr>
+          <a:xfrm>
+            <a:off x="10728657" y="4166486"/>
+            <a:ext cx="868680" cy="237744"/>
+          </a:xfrm>
+          <a:prstGeom prst="rect">
+            <a:avLst/>
+          </a:prstGeom>
+          <a:solidFill>
+            <a:srgbClr val="143847"/>
+          </a:solidFill>
+          <a:ln w="12700">
+            <a:solidFill>
+              <a:srgbClr val="143847"/>
+            </a:solidFill>
+            <a:prstDash val="solid"/>
+          </a:ln>
+        </p:spPr>
+      </p:sp>
+      <p:sp>
+        <p:nvSpPr>
+          <p:cNvPr id="56" name="Text 36">
+            <a:extLst>
+              <a:ext uri="{FF2B5EF4-FFF2-40B4-BE49-F238E27FC236}">
+                <a16:creationId xmlns:a16="http://schemas.microsoft.com/office/drawing/2014/main" id="{8D4107B0-F636-A904-F217-82A6C260D2C2}"/>
+              </a:ext>
+            </a:extLst>
+          </p:cNvPr>
+          <p:cNvSpPr/>
+          <p:nvPr/>
+        </p:nvSpPr>
+        <p:spPr>
+          <a:xfrm>
+            <a:off x="10728657" y="4175630"/>
+            <a:ext cx="868680" cy="219456"/>
+          </a:xfrm>
+          <a:prstGeom prst="rect">
+            <a:avLst/>
+          </a:prstGeom>
+          <a:noFill/>
+          <a:ln/>
+        </p:spPr>
+        <p:txBody>
+          <a:bodyPr wrap="square" lIns="0" tIns="0" rIns="0" bIns="0" rtlCol="0" anchor="ctr"/>
+          <a:lstStyle/>
+          <a:p>
+            <a:pPr marL="0" indent="0" algn="ctr">
+              <a:buNone/>
+            </a:pPr>
+            <a:r>
+              <a:rPr lang="en-US" sz="1000" b="1" dirty="0">
+                <a:solidFill>
+                  <a:srgbClr val="FFFFFF"/>
+                </a:solidFill>
+                <a:latin typeface="Calibri" pitchFamily="34" charset="0"/>
+                <a:ea typeface="Calibri" pitchFamily="34" charset="-122"/>
+                <a:cs typeface="Calibri" pitchFamily="34" charset="-120"/>
+              </a:rPr>
+              <a:t>H4</a:t>
+            </a:r>
+            <a:endParaRPr lang="en-US" sz="1000" dirty="0"/>
+          </a:p>
+        </p:txBody>
+      </p:sp>
+      <p:sp>
+        <p:nvSpPr>
+          <p:cNvPr id="57" name="Text 37">
+            <a:extLst>
+              <a:ext uri="{FF2B5EF4-FFF2-40B4-BE49-F238E27FC236}">
+                <a16:creationId xmlns:a16="http://schemas.microsoft.com/office/drawing/2014/main" id="{6CE56A8E-1E24-F803-F044-1F1B0D3E1E20}"/>
+              </a:ext>
+            </a:extLst>
+          </p:cNvPr>
+          <p:cNvSpPr/>
+          <p:nvPr/>
+        </p:nvSpPr>
+        <p:spPr>
+          <a:xfrm>
+            <a:off x="6351882" y="4404230"/>
+            <a:ext cx="5318608" cy="201168"/>
+          </a:xfrm>
+          <a:prstGeom prst="rect">
+            <a:avLst/>
+          </a:prstGeom>
+          <a:noFill/>
+          <a:ln/>
+        </p:spPr>
+        <p:txBody>
+          <a:bodyPr wrap="square" lIns="0" tIns="0" rIns="0" bIns="0" rtlCol="0" anchor="ctr"/>
+          <a:lstStyle/>
+          <a:p>
+            <a:pPr marL="0" indent="0">
+              <a:buNone/>
+            </a:pPr>
+            <a:r>
+              <a:rPr lang="en-US" sz="900" i="1" dirty="0">
+                <a:solidFill>
+                  <a:srgbClr val="5A6770"/>
+                </a:solidFill>
+                <a:latin typeface="Calibri" pitchFamily="34" charset="0"/>
+                <a:ea typeface="Calibri" pitchFamily="34" charset="-122"/>
+                <a:cs typeface="Calibri" pitchFamily="34" charset="-120"/>
+              </a:rPr>
+              <a:t>Platform log</a:t>
+            </a:r>
+            <a:endParaRPr lang="en-US" sz="900" dirty="0"/>
+          </a:p>
+        </p:txBody>
+      </p:sp>
+      <p:sp>
+        <p:nvSpPr>
+          <p:cNvPr id="58" name="Text 38">
+            <a:extLst>
+              <a:ext uri="{FF2B5EF4-FFF2-40B4-BE49-F238E27FC236}">
+                <a16:creationId xmlns:a16="http://schemas.microsoft.com/office/drawing/2014/main" id="{C40C0D24-1132-3F73-F043-483109F3493C}"/>
+              </a:ext>
+            </a:extLst>
+          </p:cNvPr>
+          <p:cNvSpPr/>
+          <p:nvPr/>
+        </p:nvSpPr>
+        <p:spPr>
+          <a:xfrm>
+            <a:off x="6351882" y="4605398"/>
+            <a:ext cx="5318608" cy="360180"/>
+          </a:xfrm>
+          <a:prstGeom prst="rect">
+            <a:avLst/>
+          </a:prstGeom>
+          <a:noFill/>
+          <a:ln/>
+        </p:spPr>
+        <p:txBody>
+          <a:bodyPr wrap="square" lIns="0" tIns="0" rIns="0" bIns="0" rtlCol="0" anchor="t"/>
+          <a:lstStyle/>
+          <a:p>
+            <a:pPr marL="0" indent="0">
+              <a:buNone/>
+            </a:pPr>
+            <a:r>
+              <a:rPr lang="en-US" sz="1050" dirty="0">
+                <a:solidFill>
+                  <a:srgbClr val="1A1A1A"/>
+                </a:solidFill>
+                <a:latin typeface="Calibri" pitchFamily="34" charset="0"/>
+                <a:ea typeface="Calibri" pitchFamily="34" charset="-122"/>
+                <a:cs typeface="Calibri" pitchFamily="34" charset="-120"/>
+              </a:rPr>
+              <a:t>Communications and resource management are note aided — so they reveal whether reading less in the panel actually frees attention elsewhere. We are measuring performance in these tasks.</a:t>
+            </a:r>
+            <a:endParaRPr lang="en-US" sz="1050" dirty="0"/>
           </a:p>
         </p:txBody>
       </p:sp>

</xml_diff>